<commit_message>
update presentation, add pdf
</commit_message>
<xml_diff>
--- a/prezentacja.pptx
+++ b/prezentacja.pptx
@@ -1,14 +1,14 @@
 
 <file path=ppt/presentation.xml><?xml version="1.0" encoding="utf-8"?>
-<p:presentation xmlns:a="http://schemas.openxmlformats.org/drawingml/2006/main" xmlns:r="http://schemas.openxmlformats.org/officeDocument/2006/relationships" xmlns:p="http://schemas.openxmlformats.org/presentationml/2006/main" xmlns:m="http://schemas.openxmlformats.org/officeDocument/2006/math" xmlns:w="http://schemas.openxmlformats.org/wordprocessingml/2006/main" saveSubsetFonts="1">
+<p:presentation xmlns:a="http://schemas.openxmlformats.org/drawingml/2006/main" xmlns:r="http://schemas.openxmlformats.org/officeDocument/2006/relationships" xmlns:p="http://schemas.openxmlformats.org/presentationml/2006/main" saveSubsetFonts="1">
   <p:sldMasterIdLst>
     <p:sldMasterId id="2147483648" r:id="rId1"/>
   </p:sldMasterIdLst>
   <p:notesMasterIdLst>
-    <p:notesMasterId r:id="rId5"/>
+    <p:notesMasterId r:id="rId3"/>
   </p:notesMasterIdLst>
   <p:sldIdLst>
-    <p:sldId id="256" r:id="rId4"/>
+    <p:sldId id="256" r:id="rId2"/>
   </p:sldIdLst>
   <p:sldSz cx="12192000" cy="6858000"/>
   <p:notesSz cx="6858000" cy="9144000"/>
@@ -107,12 +107,28 @@
       </a:defRPr>
     </a:lvl9pPr>
   </p:defaultTextStyle>
+  <p:extLst>
+    <p:ext uri="{EFAFB233-063F-42B5-8137-9DF3F51BA10A}">
+      <p15:sldGuideLst xmlns:p15="http://schemas.microsoft.com/office/powerpoint/2012/main">
+        <p15:guide id="1" pos="3840">
+          <p15:clr>
+            <a:srgbClr val="A4A3A4"/>
+          </p15:clr>
+        </p15:guide>
+        <p15:guide id="2" orient="horz" pos="2160">
+          <p15:clr>
+            <a:srgbClr val="A4A3A4"/>
+          </p15:clr>
+        </p15:guide>
+      </p15:sldGuideLst>
+    </p:ext>
+  </p:extLst>
 </p:presentation>
 </file>
 
 <file path=ppt/notesMasters/notesMaster1.xml><?xml version="1.0" encoding="utf-8"?>
 <p:notesMaster xmlns:a="http://schemas.openxmlformats.org/drawingml/2006/main" xmlns:r="http://schemas.openxmlformats.org/officeDocument/2006/relationships" xmlns:p="http://schemas.openxmlformats.org/presentationml/2006/main">
-  <p:cSld name="">
+  <p:cSld>
     <p:bg>
       <p:bgRef idx="1001">
         <a:schemeClr val="bg1"/>
@@ -198,7 +214,7 @@
             </a:pPr>
             <a:fld id="{3632E96E-41F7-40C5-8419-297958CC00FA}" type="datetimeFigureOut">
               <a:rPr lang="en-US"/>
-              <a:t>10/30/2013</a:t>
+              <a:t>3/24/2026</a:t>
             </a:fld>
             <a:endParaRPr lang="en-US"/>
           </a:p>
@@ -208,7 +224,7 @@
         <p:nvSpPr>
           <p:cNvPr id="1979169806" name="Slide Image Placeholder 3"/>
           <p:cNvSpPr>
-            <a:spLocks noChangeAspect="1" noGrp="1" noRot="1"/>
+            <a:spLocks noGrp="1" noRot="1" noChangeAspect="1"/>
           </p:cNvSpPr>
           <p:nvPr>
             <p:ph type="sldImg" idx="2"/>
@@ -310,7 +326,6 @@
               <a:rPr lang="en-US"/>
               <a:t>Fifth level</a:t>
             </a:r>
-            <a:endParaRPr lang="en-US"/>
           </a:p>
         </p:txBody>
       </p:sp>
@@ -485,8 +500,8 @@
 </file>
 
 <file path=ppt/notesSlides/notesSlide1.xml><?xml version="1.0" encoding="utf-8"?>
-<p:notes xmlns:a="http://schemas.openxmlformats.org/drawingml/2006/main" xmlns:r="http://schemas.openxmlformats.org/officeDocument/2006/relationships" xmlns:p="http://schemas.openxmlformats.org/presentationml/2006/main" xmlns:m="http://schemas.openxmlformats.org/officeDocument/2006/math" xmlns:w="http://schemas.openxmlformats.org/wordprocessingml/2006/main">
-  <p:cSld name="">
+<p:notes xmlns:a="http://schemas.openxmlformats.org/drawingml/2006/main" xmlns:r="http://schemas.openxmlformats.org/officeDocument/2006/relationships" xmlns:p="http://schemas.openxmlformats.org/presentationml/2006/main">
+  <p:cSld>
     <p:spTree>
       <p:nvGrpSpPr>
         <p:cNvPr id="1" name=""/>
@@ -505,7 +520,7 @@
         <p:nvSpPr>
           <p:cNvPr id="1387991312" name="Slide Image Placeholder 1"/>
           <p:cNvSpPr>
-            <a:spLocks noChangeAspect="1" noGrp="1" noRot="1"/>
+            <a:spLocks noGrp="1" noRot="1" noChangeAspect="1"/>
           </p:cNvSpPr>
           <p:nvPr>
             <p:ph type="sldImg"/>
@@ -578,7 +593,7 @@
 </file>
 
 <file path=ppt/slideLayouts/slideLayout1.xml><?xml version="1.0" encoding="utf-8"?>
-<p:sldLayout xmlns:a="http://schemas.openxmlformats.org/drawingml/2006/main" xmlns:r="http://schemas.openxmlformats.org/officeDocument/2006/relationships" xmlns:p="http://schemas.openxmlformats.org/presentationml/2006/main" xmlns:m="http://schemas.openxmlformats.org/officeDocument/2006/math" xmlns:w="http://schemas.openxmlformats.org/wordprocessingml/2006/main" matchingName="" preserve="1" showMasterPhAnim="0" showMasterSp="1" type="title" userDrawn="1">
+<p:sldLayout xmlns:a="http://schemas.openxmlformats.org/drawingml/2006/main" xmlns:r="http://schemas.openxmlformats.org/officeDocument/2006/relationships" xmlns:p="http://schemas.openxmlformats.org/presentationml/2006/main" showMasterPhAnim="0" type="title" preserve="1" userDrawn="1">
   <p:cSld name="Title Slide">
     <p:spTree>
       <p:nvGrpSpPr>
@@ -625,7 +640,6 @@
               <a:rPr lang="en-US"/>
               <a:t>Click to edit Master title style</a:t>
             </a:r>
-            <a:endParaRPr lang="en-US"/>
           </a:p>
         </p:txBody>
       </p:sp>
@@ -693,7 +707,6 @@
               <a:rPr lang="en-US"/>
               <a:t>Click to edit Master subtitle style</a:t>
             </a:r>
-            <a:endParaRPr lang="en-US"/>
           </a:p>
         </p:txBody>
       </p:sp>
@@ -717,7 +730,7 @@
             </a:pPr>
             <a:fld id="{BCC18F51-09EC-435C-A3BA-64A766E099C0}" type="datetimeFigureOut">
               <a:rPr lang="en-US"/>
-              <a:t>30.10.2013</a:t>
+              <a:t>3/24/2026</a:t>
             </a:fld>
             <a:endParaRPr lang="en-US"/>
           </a:p>
@@ -780,7 +793,7 @@
 </file>
 
 <file path=ppt/slideLayouts/slideLayout10.xml><?xml version="1.0" encoding="utf-8"?>
-<p:sldLayout xmlns:a="http://schemas.openxmlformats.org/drawingml/2006/main" xmlns:r="http://schemas.openxmlformats.org/officeDocument/2006/relationships" xmlns:p="http://schemas.openxmlformats.org/presentationml/2006/main" xmlns:m="http://schemas.openxmlformats.org/officeDocument/2006/math" xmlns:w="http://schemas.openxmlformats.org/wordprocessingml/2006/main" matchingName="" preserve="1" showMasterPhAnim="0" showMasterSp="1" type="vertTx" userDrawn="1">
+<p:sldLayout xmlns:a="http://schemas.openxmlformats.org/drawingml/2006/main" xmlns:r="http://schemas.openxmlformats.org/officeDocument/2006/relationships" xmlns:p="http://schemas.openxmlformats.org/presentationml/2006/main" showMasterPhAnim="0" type="vertTx" preserve="1" userDrawn="1">
   <p:cSld name="Title and Vertical Text">
     <p:spTree>
       <p:nvGrpSpPr>
@@ -818,7 +831,6 @@
               <a:rPr lang="en-US"/>
               <a:t>Click to edit Master title style</a:t>
             </a:r>
-            <a:endParaRPr lang="en-US"/>
           </a:p>
         </p:txBody>
       </p:sp>
@@ -884,7 +896,6 @@
               <a:rPr lang="en-US"/>
               <a:t>Fifth level</a:t>
             </a:r>
-            <a:endParaRPr lang="en-US"/>
           </a:p>
         </p:txBody>
       </p:sp>
@@ -908,7 +919,7 @@
             </a:pPr>
             <a:fld id="{BCC18F51-09EC-435C-A3BA-64A766E099C0}" type="datetimeFigureOut">
               <a:rPr lang="en-US"/>
-              <a:t>30.10.2013</a:t>
+              <a:t>3/24/2026</a:t>
             </a:fld>
             <a:endParaRPr lang="en-US"/>
           </a:p>
@@ -971,7 +982,7 @@
 </file>
 
 <file path=ppt/slideLayouts/slideLayout11.xml><?xml version="1.0" encoding="utf-8"?>
-<p:sldLayout xmlns:a="http://schemas.openxmlformats.org/drawingml/2006/main" xmlns:r="http://schemas.openxmlformats.org/officeDocument/2006/relationships" xmlns:p="http://schemas.openxmlformats.org/presentationml/2006/main" xmlns:m="http://schemas.openxmlformats.org/officeDocument/2006/math" xmlns:w="http://schemas.openxmlformats.org/wordprocessingml/2006/main" matchingName="" preserve="1" showMasterPhAnim="0" showMasterSp="1" type="vertTitleAndTx" userDrawn="1">
+<p:sldLayout xmlns:a="http://schemas.openxmlformats.org/drawingml/2006/main" xmlns:r="http://schemas.openxmlformats.org/officeDocument/2006/relationships" xmlns:p="http://schemas.openxmlformats.org/presentationml/2006/main" showMasterPhAnim="0" type="vertTitleAndTx" preserve="1" userDrawn="1">
   <p:cSld name="Vertical Title and Text">
     <p:spTree>
       <p:nvGrpSpPr>
@@ -1014,7 +1025,6 @@
               <a:rPr lang="en-US"/>
               <a:t>Click to edit Master title style</a:t>
             </a:r>
-            <a:endParaRPr lang="en-US"/>
           </a:p>
         </p:txBody>
       </p:sp>
@@ -1085,7 +1095,6 @@
               <a:rPr lang="en-US"/>
               <a:t>Fifth level</a:t>
             </a:r>
-            <a:endParaRPr lang="en-US"/>
           </a:p>
         </p:txBody>
       </p:sp>
@@ -1109,7 +1118,7 @@
             </a:pPr>
             <a:fld id="{BCC18F51-09EC-435C-A3BA-64A766E099C0}" type="datetimeFigureOut">
               <a:rPr lang="en-US"/>
-              <a:t>30.10.2013</a:t>
+              <a:t>3/24/2026</a:t>
             </a:fld>
             <a:endParaRPr lang="en-US"/>
           </a:p>
@@ -1172,7 +1181,7 @@
 </file>
 
 <file path=ppt/slideLayouts/slideLayout2.xml><?xml version="1.0" encoding="utf-8"?>
-<p:sldLayout xmlns:a="http://schemas.openxmlformats.org/drawingml/2006/main" xmlns:r="http://schemas.openxmlformats.org/officeDocument/2006/relationships" xmlns:p="http://schemas.openxmlformats.org/presentationml/2006/main" xmlns:m="http://schemas.openxmlformats.org/officeDocument/2006/math" xmlns:w="http://schemas.openxmlformats.org/wordprocessingml/2006/main" matchingName="" preserve="1" showMasterPhAnim="0" showMasterSp="1" type="obj" userDrawn="1">
+<p:sldLayout xmlns:a="http://schemas.openxmlformats.org/drawingml/2006/main" xmlns:r="http://schemas.openxmlformats.org/officeDocument/2006/relationships" xmlns:p="http://schemas.openxmlformats.org/presentationml/2006/main" showMasterPhAnim="0" type="obj" preserve="1" userDrawn="1">
   <p:cSld name="Title and Content">
     <p:spTree>
       <p:nvGrpSpPr>
@@ -1210,7 +1219,6 @@
               <a:rPr lang="en-US"/>
               <a:t>Click to edit Master title style</a:t>
             </a:r>
-            <a:endParaRPr lang="en-US"/>
           </a:p>
         </p:txBody>
       </p:sp>
@@ -1276,7 +1284,6 @@
               <a:rPr lang="en-US"/>
               <a:t>Fifth level</a:t>
             </a:r>
-            <a:endParaRPr lang="en-US"/>
           </a:p>
         </p:txBody>
       </p:sp>
@@ -1300,7 +1307,7 @@
             </a:pPr>
             <a:fld id="{BCC18F51-09EC-435C-A3BA-64A766E099C0}" type="datetimeFigureOut">
               <a:rPr lang="en-US"/>
-              <a:t>30.10.2013</a:t>
+              <a:t>3/24/2026</a:t>
             </a:fld>
             <a:endParaRPr lang="en-US"/>
           </a:p>
@@ -1363,7 +1370,7 @@
 </file>
 
 <file path=ppt/slideLayouts/slideLayout3.xml><?xml version="1.0" encoding="utf-8"?>
-<p:sldLayout xmlns:a="http://schemas.openxmlformats.org/drawingml/2006/main" xmlns:r="http://schemas.openxmlformats.org/officeDocument/2006/relationships" xmlns:p="http://schemas.openxmlformats.org/presentationml/2006/main" xmlns:m="http://schemas.openxmlformats.org/officeDocument/2006/math" xmlns:w="http://schemas.openxmlformats.org/wordprocessingml/2006/main" matchingName="" preserve="1" showMasterPhAnim="0" showMasterSp="1" type="secHead" userDrawn="1">
+<p:sldLayout xmlns:a="http://schemas.openxmlformats.org/drawingml/2006/main" xmlns:r="http://schemas.openxmlformats.org/officeDocument/2006/relationships" xmlns:p="http://schemas.openxmlformats.org/presentationml/2006/main" showMasterPhAnim="0" type="secHead" preserve="1" userDrawn="1">
   <p:cSld name="Section Header">
     <p:spTree>
       <p:nvGrpSpPr>
@@ -1410,7 +1417,6 @@
               <a:rPr lang="en-US"/>
               <a:t>Click to edit Master title style</a:t>
             </a:r>
-            <a:endParaRPr lang="en-US"/>
           </a:p>
         </p:txBody>
       </p:sp>
@@ -1556,7 +1562,7 @@
             </a:pPr>
             <a:fld id="{BCC18F51-09EC-435C-A3BA-64A766E099C0}" type="datetimeFigureOut">
               <a:rPr lang="en-US"/>
-              <a:t>30.10.2013</a:t>
+              <a:t>3/24/2026</a:t>
             </a:fld>
             <a:endParaRPr lang="en-US"/>
           </a:p>
@@ -1619,7 +1625,7 @@
 </file>
 
 <file path=ppt/slideLayouts/slideLayout4.xml><?xml version="1.0" encoding="utf-8"?>
-<p:sldLayout xmlns:a="http://schemas.openxmlformats.org/drawingml/2006/main" xmlns:r="http://schemas.openxmlformats.org/officeDocument/2006/relationships" xmlns:p="http://schemas.openxmlformats.org/presentationml/2006/main" xmlns:m="http://schemas.openxmlformats.org/officeDocument/2006/math" xmlns:w="http://schemas.openxmlformats.org/wordprocessingml/2006/main" matchingName="" preserve="1" showMasterPhAnim="0" showMasterSp="1" type="twoObj" userDrawn="1">
+<p:sldLayout xmlns:a="http://schemas.openxmlformats.org/drawingml/2006/main" xmlns:r="http://schemas.openxmlformats.org/officeDocument/2006/relationships" xmlns:p="http://schemas.openxmlformats.org/presentationml/2006/main" showMasterPhAnim="0" type="twoObj" preserve="1" userDrawn="1">
   <p:cSld name="Two Content">
     <p:spTree>
       <p:nvGrpSpPr>
@@ -1657,7 +1663,6 @@
               <a:rPr lang="en-US"/>
               <a:t>Click to edit Master title style</a:t>
             </a:r>
-            <a:endParaRPr lang="en-US"/>
           </a:p>
         </p:txBody>
       </p:sp>
@@ -1728,7 +1733,6 @@
               <a:rPr lang="en-US"/>
               <a:t>Fifth level</a:t>
             </a:r>
-            <a:endParaRPr lang="en-US"/>
           </a:p>
         </p:txBody>
       </p:sp>
@@ -1799,7 +1803,6 @@
               <a:rPr lang="en-US"/>
               <a:t>Fifth level</a:t>
             </a:r>
-            <a:endParaRPr lang="en-US"/>
           </a:p>
         </p:txBody>
       </p:sp>
@@ -1823,7 +1826,7 @@
             </a:pPr>
             <a:fld id="{BCC18F51-09EC-435C-A3BA-64A766E099C0}" type="datetimeFigureOut">
               <a:rPr lang="en-US"/>
-              <a:t>30.10.2013</a:t>
+              <a:t>3/24/2026</a:t>
             </a:fld>
             <a:endParaRPr lang="en-US"/>
           </a:p>
@@ -1886,7 +1889,7 @@
 </file>
 
 <file path=ppt/slideLayouts/slideLayout5.xml><?xml version="1.0" encoding="utf-8"?>
-<p:sldLayout xmlns:a="http://schemas.openxmlformats.org/drawingml/2006/main" xmlns:r="http://schemas.openxmlformats.org/officeDocument/2006/relationships" xmlns:p="http://schemas.openxmlformats.org/presentationml/2006/main" xmlns:m="http://schemas.openxmlformats.org/officeDocument/2006/math" xmlns:w="http://schemas.openxmlformats.org/wordprocessingml/2006/main" matchingName="" preserve="1" showMasterPhAnim="0" showMasterSp="1" type="twoTxTwoObj" userDrawn="1">
+<p:sldLayout xmlns:a="http://schemas.openxmlformats.org/drawingml/2006/main" xmlns:r="http://schemas.openxmlformats.org/officeDocument/2006/relationships" xmlns:p="http://schemas.openxmlformats.org/presentationml/2006/main" showMasterPhAnim="0" type="twoTxTwoObj" preserve="1" userDrawn="1">
   <p:cSld name="Comparison">
     <p:spTree>
       <p:nvGrpSpPr>
@@ -1929,7 +1932,6 @@
               <a:rPr lang="en-US"/>
               <a:t>Click to edit Master title style</a:t>
             </a:r>
-            <a:endParaRPr lang="en-US"/>
           </a:p>
         </p:txBody>
       </p:sp>
@@ -2068,7 +2070,6 @@
               <a:rPr lang="en-US"/>
               <a:t>Fifth level</a:t>
             </a:r>
-            <a:endParaRPr lang="en-US"/>
           </a:p>
         </p:txBody>
       </p:sp>
@@ -2207,7 +2208,6 @@
               <a:rPr lang="en-US"/>
               <a:t>Fifth level</a:t>
             </a:r>
-            <a:endParaRPr lang="en-US"/>
           </a:p>
         </p:txBody>
       </p:sp>
@@ -2231,7 +2231,7 @@
             </a:pPr>
             <a:fld id="{BCC18F51-09EC-435C-A3BA-64A766E099C0}" type="datetimeFigureOut">
               <a:rPr lang="en-US"/>
-              <a:t>30.10.2013</a:t>
+              <a:t>3/24/2026</a:t>
             </a:fld>
             <a:endParaRPr lang="en-US"/>
           </a:p>
@@ -2294,7 +2294,7 @@
 </file>
 
 <file path=ppt/slideLayouts/slideLayout6.xml><?xml version="1.0" encoding="utf-8"?>
-<p:sldLayout xmlns:a="http://schemas.openxmlformats.org/drawingml/2006/main" xmlns:r="http://schemas.openxmlformats.org/officeDocument/2006/relationships" xmlns:p="http://schemas.openxmlformats.org/presentationml/2006/main" xmlns:m="http://schemas.openxmlformats.org/officeDocument/2006/math" xmlns:w="http://schemas.openxmlformats.org/wordprocessingml/2006/main" matchingName="" preserve="1" showMasterPhAnim="0" showMasterSp="1" type="titleOnly" userDrawn="1">
+<p:sldLayout xmlns:a="http://schemas.openxmlformats.org/drawingml/2006/main" xmlns:r="http://schemas.openxmlformats.org/officeDocument/2006/relationships" xmlns:p="http://schemas.openxmlformats.org/presentationml/2006/main" showMasterPhAnim="0" type="titleOnly" preserve="1" userDrawn="1">
   <p:cSld name="Title Only">
     <p:spTree>
       <p:nvGrpSpPr>
@@ -2332,7 +2332,6 @@
               <a:rPr lang="en-US"/>
               <a:t>Click to edit Master title style</a:t>
             </a:r>
-            <a:endParaRPr lang="en-US"/>
           </a:p>
         </p:txBody>
       </p:sp>
@@ -2356,7 +2355,7 @@
             </a:pPr>
             <a:fld id="{BCC18F51-09EC-435C-A3BA-64A766E099C0}" type="datetimeFigureOut">
               <a:rPr lang="en-US"/>
-              <a:t>30.10.2013</a:t>
+              <a:t>3/24/2026</a:t>
             </a:fld>
             <a:endParaRPr lang="en-US"/>
           </a:p>
@@ -2419,7 +2418,7 @@
 </file>
 
 <file path=ppt/slideLayouts/slideLayout7.xml><?xml version="1.0" encoding="utf-8"?>
-<p:sldLayout xmlns:a="http://schemas.openxmlformats.org/drawingml/2006/main" xmlns:r="http://schemas.openxmlformats.org/officeDocument/2006/relationships" xmlns:p="http://schemas.openxmlformats.org/presentationml/2006/main" xmlns:m="http://schemas.openxmlformats.org/officeDocument/2006/math" xmlns:w="http://schemas.openxmlformats.org/wordprocessingml/2006/main" matchingName="" preserve="1" showMasterPhAnim="0" showMasterSp="1" type="blank" userDrawn="1">
+<p:sldLayout xmlns:a="http://schemas.openxmlformats.org/drawingml/2006/main" xmlns:r="http://schemas.openxmlformats.org/officeDocument/2006/relationships" xmlns:p="http://schemas.openxmlformats.org/presentationml/2006/main" showMasterPhAnim="0" type="blank" preserve="1" userDrawn="1">
   <p:cSld name="Blank">
     <p:spTree>
       <p:nvGrpSpPr>
@@ -2455,7 +2454,7 @@
             </a:pPr>
             <a:fld id="{BCC18F51-09EC-435C-A3BA-64A766E099C0}" type="datetimeFigureOut">
               <a:rPr lang="en-US"/>
-              <a:t>30.10.2013</a:t>
+              <a:t>3/24/2026</a:t>
             </a:fld>
             <a:endParaRPr lang="en-US"/>
           </a:p>
@@ -2518,7 +2517,7 @@
 </file>
 
 <file path=ppt/slideLayouts/slideLayout8.xml><?xml version="1.0" encoding="utf-8"?>
-<p:sldLayout xmlns:a="http://schemas.openxmlformats.org/drawingml/2006/main" xmlns:r="http://schemas.openxmlformats.org/officeDocument/2006/relationships" xmlns:p="http://schemas.openxmlformats.org/presentationml/2006/main" xmlns:m="http://schemas.openxmlformats.org/officeDocument/2006/math" xmlns:w="http://schemas.openxmlformats.org/wordprocessingml/2006/main" matchingName="" preserve="1" showMasterPhAnim="0" showMasterSp="1" type="objTx" userDrawn="1">
+<p:sldLayout xmlns:a="http://schemas.openxmlformats.org/drawingml/2006/main" xmlns:r="http://schemas.openxmlformats.org/officeDocument/2006/relationships" xmlns:p="http://schemas.openxmlformats.org/presentationml/2006/main" showMasterPhAnim="0" type="objTx" preserve="1" userDrawn="1">
   <p:cSld name="Content with Caption">
     <p:spTree>
       <p:nvGrpSpPr>
@@ -2565,7 +2564,6 @@
               <a:rPr lang="en-US"/>
               <a:t>Click to edit Master title style</a:t>
             </a:r>
-            <a:endParaRPr lang="en-US"/>
           </a:p>
         </p:txBody>
       </p:sp>
@@ -2664,7 +2662,6 @@
               <a:rPr lang="en-US"/>
               <a:t>Fifth level</a:t>
             </a:r>
-            <a:endParaRPr lang="en-US"/>
           </a:p>
         </p:txBody>
       </p:sp>
@@ -2756,7 +2753,7 @@
             </a:pPr>
             <a:fld id="{BCC18F51-09EC-435C-A3BA-64A766E099C0}" type="datetimeFigureOut">
               <a:rPr lang="en-US"/>
-              <a:t>30.10.2013</a:t>
+              <a:t>3/24/2026</a:t>
             </a:fld>
             <a:endParaRPr lang="en-US"/>
           </a:p>
@@ -2819,7 +2816,7 @@
 </file>
 
 <file path=ppt/slideLayouts/slideLayout9.xml><?xml version="1.0" encoding="utf-8"?>
-<p:sldLayout xmlns:a="http://schemas.openxmlformats.org/drawingml/2006/main" xmlns:r="http://schemas.openxmlformats.org/officeDocument/2006/relationships" xmlns:p="http://schemas.openxmlformats.org/presentationml/2006/main" xmlns:m="http://schemas.openxmlformats.org/officeDocument/2006/math" xmlns:w="http://schemas.openxmlformats.org/wordprocessingml/2006/main" matchingName="" preserve="1" showMasterPhAnim="0" showMasterSp="1" type="picTx" userDrawn="1">
+<p:sldLayout xmlns:a="http://schemas.openxmlformats.org/drawingml/2006/main" xmlns:r="http://schemas.openxmlformats.org/officeDocument/2006/relationships" xmlns:p="http://schemas.openxmlformats.org/presentationml/2006/main" showMasterPhAnim="0" type="picTx" preserve="1" userDrawn="1">
   <p:cSld name="Picture with Caption">
     <p:spTree>
       <p:nvGrpSpPr>
@@ -2866,7 +2863,6 @@
               <a:rPr lang="en-US"/>
               <a:t>Click to edit Master title style</a:t>
             </a:r>
-            <a:endParaRPr lang="en-US"/>
           </a:p>
         </p:txBody>
       </p:sp>
@@ -2874,7 +2870,7 @@
         <p:nvSpPr>
           <p:cNvPr id="71940099" name="Picture Placeholder 2"/>
           <p:cNvSpPr>
-            <a:spLocks noChangeAspect="1" noGrp="1"/>
+            <a:spLocks noGrp="1" noChangeAspect="1"/>
           </p:cNvSpPr>
           <p:nvPr>
             <p:ph type="pic" idx="1"/>
@@ -2934,7 +2930,6 @@
               <a:rPr lang="en-US"/>
               <a:t>Click icon to add picture</a:t>
             </a:r>
-            <a:endParaRPr lang="en-US"/>
           </a:p>
         </p:txBody>
       </p:sp>
@@ -3026,7 +3021,7 @@
             </a:pPr>
             <a:fld id="{BCC18F51-09EC-435C-A3BA-64A766E099C0}" type="datetimeFigureOut">
               <a:rPr lang="en-US"/>
-              <a:t>30.10.2013</a:t>
+              <a:t>3/24/2026</a:t>
             </a:fld>
             <a:endParaRPr lang="en-US"/>
           </a:p>
@@ -3089,8 +3084,8 @@
 </file>
 
 <file path=ppt/slideMasters/slideMaster1.xml><?xml version="1.0" encoding="utf-8"?>
-<p:sldMaster xmlns:a="http://schemas.openxmlformats.org/drawingml/2006/main" xmlns:r="http://schemas.openxmlformats.org/officeDocument/2006/relationships" xmlns:p="http://schemas.openxmlformats.org/presentationml/2006/main" xmlns:m="http://schemas.openxmlformats.org/officeDocument/2006/math" xmlns:w="http://schemas.openxmlformats.org/wordprocessingml/2006/main" preserve="0">
-  <p:cSld name="">
+<p:sldMaster xmlns:a="http://schemas.openxmlformats.org/drawingml/2006/main" xmlns:r="http://schemas.openxmlformats.org/officeDocument/2006/relationships" xmlns:p="http://schemas.openxmlformats.org/presentationml/2006/main">
+  <p:cSld>
     <p:bg>
       <p:bgRef idx="1001">
         <a:schemeClr val="bg1"/>
@@ -3142,7 +3137,6 @@
               <a:rPr lang="en-US"/>
               <a:t>Click to edit Master title style</a:t>
             </a:r>
-            <a:endParaRPr lang="en-US"/>
           </a:p>
         </p:txBody>
       </p:sp>
@@ -3218,7 +3212,6 @@
               <a:rPr lang="en-US"/>
               <a:t>Fifth level</a:t>
             </a:r>
-            <a:endParaRPr lang="en-US"/>
           </a:p>
         </p:txBody>
       </p:sp>
@@ -3260,7 +3253,7 @@
             </a:pPr>
             <a:fld id="{BCC18F51-09EC-435C-A3BA-64A766E099C0}" type="datetimeFigureOut">
               <a:rPr lang="en-US"/>
-              <a:t>30.10.2013</a:t>
+              <a:t>3/24/2026</a:t>
             </a:fld>
             <a:endParaRPr lang="en-US"/>
           </a:p>
@@ -3650,8 +3643,8 @@
 </file>
 
 <file path=ppt/slides/slide1.xml><?xml version="1.0" encoding="utf-8"?>
-<p:sld xmlns:a="http://schemas.openxmlformats.org/drawingml/2006/main" xmlns:r="http://schemas.openxmlformats.org/officeDocument/2006/relationships" xmlns:p="http://schemas.openxmlformats.org/presentationml/2006/main" xmlns:m="http://schemas.openxmlformats.org/officeDocument/2006/math" xmlns:w="http://schemas.openxmlformats.org/wordprocessingml/2006/main" xmlns:mc="http://schemas.openxmlformats.org/markup-compatibility/2006" showMasterPhAnim="0" showMasterSp="1" show="1">
-  <p:cSld name="">
+<p:sld xmlns:a="http://schemas.openxmlformats.org/drawingml/2006/main" xmlns:r="http://schemas.openxmlformats.org/officeDocument/2006/relationships" xmlns:p="http://schemas.openxmlformats.org/presentationml/2006/main" showMasterPhAnim="0">
+  <p:cSld>
     <p:spTree>
       <p:nvGrpSpPr>
         <p:cNvPr id="1" name=""/>
@@ -3677,7 +3670,7 @@
           </p:nvPr>
         </p:nvSpPr>
         <p:spPr bwMode="auto">
-          <a:xfrm flipH="0" flipV="0">
+          <a:xfrm>
             <a:off x="1523999" y="1063624"/>
             <a:ext cx="9144000" cy="509587"/>
           </a:xfrm>
@@ -3730,7 +3723,7 @@
           </p:nvPr>
         </p:nvSpPr>
         <p:spPr bwMode="auto">
-          <a:xfrm flipH="0" flipV="0">
+          <a:xfrm>
             <a:off x="1619249" y="1935162"/>
             <a:ext cx="9144000" cy="1906587"/>
           </a:xfrm>
@@ -3782,18 +3775,7 @@
                 <a:ea typeface="Arial"/>
                 <a:cs typeface="Arial"/>
               </a:rPr>
-              <a:t> </a:t>
-            </a:r>
-            <a:r>
-              <a:rPr sz="1500" b="0" i="0" u="none">
-                <a:solidFill>
-                  <a:srgbClr val="000000"/>
-                </a:solidFill>
-                <a:latin typeface="Arial"/>
-                <a:ea typeface="Arial"/>
-                <a:cs typeface="Arial"/>
-              </a:rPr>
-              <a:t>Zbudowanie modelu AI rekomendującego optymalną trasę i środek transportu.</a:t>
+              <a:t> Zbudowanie modelu AI rekomendującego optymalną trasę i środek transportu.</a:t>
             </a:r>
             <a:endParaRPr sz="1500">
               <a:latin typeface="Arial"/>
@@ -3824,18 +3806,7 @@
                 <a:ea typeface="Arial"/>
                 <a:cs typeface="Arial"/>
               </a:rPr>
-              <a:t> </a:t>
-            </a:r>
-            <a:r>
-              <a:rPr sz="1500" b="0" i="0" u="none">
-                <a:solidFill>
-                  <a:srgbClr val="000000"/>
-                </a:solidFill>
-                <a:latin typeface="Arial"/>
-                <a:ea typeface="Arial"/>
-                <a:cs typeface="Arial"/>
-              </a:rPr>
-              <a:t>Codzienne dylematy studentów – minimalizacja czasu podróży i unikanie spóźnień.</a:t>
+              <a:t> Codzienne dylematy studentów – minimalizacja czasu podróży i unikanie spóźnień.</a:t>
             </a:r>
             <a:endParaRPr sz="1500">
               <a:latin typeface="Arial"/>
@@ -3853,13 +3824,13 @@
           <p:nvPr/>
         </p:nvSpPr>
         <p:spPr bwMode="auto">
-          <a:xfrm flipH="0" flipV="0">
+          <a:xfrm>
             <a:off x="1619249" y="3555999"/>
             <a:ext cx="9144000" cy="2682874"/>
           </a:xfrm>
         </p:spPr>
         <p:txBody>
-          <a:bodyPr vertOverflow="overflow" horzOverflow="overflow" vert="horz" wrap="square" lIns="91440" tIns="45720" rIns="91440" bIns="45720" numCol="1" spcCol="0" rtlCol="0" fromWordArt="0" anchor="t" anchorCtr="0" forceAA="0" upright="0" compatLnSpc="0">
+          <a:bodyPr vertOverflow="overflow" horzOverflow="overflow" vert="horz" wrap="square" lIns="91440" tIns="45720" rIns="91440" bIns="45720" numCol="1" spcCol="0" rtlCol="0" fromWordArt="0" anchor="t" anchorCtr="0" forceAA="0" compatLnSpc="0">
             <a:normAutofit/>
           </a:bodyPr>
           <a:lstStyle>
@@ -4031,17 +4002,39 @@
               <a:defRPr/>
             </a:pPr>
             <a:r>
-              <a:rPr sz="1500" b="1" i="0" u="none">
-                <a:solidFill>
-                  <a:srgbClr val="000000"/>
-                </a:solidFill>
-                <a:latin typeface="Arial"/>
-                <a:ea typeface="Arial"/>
-                <a:cs typeface="Arial"/>
-              </a:rPr>
-              <a:t>2. JAK? (Technologie i Dane)</a:t>
-            </a:r>
-            <a:endParaRPr sz="1500">
+              <a:rPr sz="1500" b="1" i="0" u="none" dirty="0">
+                <a:solidFill>
+                  <a:srgbClr val="000000"/>
+                </a:solidFill>
+                <a:latin typeface="Arial"/>
+                <a:ea typeface="Arial"/>
+                <a:cs typeface="Arial"/>
+              </a:rPr>
+              <a:t>2. JAK? (Technologie </a:t>
+            </a:r>
+            <a:r>
+              <a:rPr sz="1500" b="1" i="0" u="none" dirty="0" err="1">
+                <a:solidFill>
+                  <a:srgbClr val="000000"/>
+                </a:solidFill>
+                <a:latin typeface="Arial"/>
+                <a:ea typeface="Arial"/>
+                <a:cs typeface="Arial"/>
+              </a:rPr>
+              <a:t>i</a:t>
+            </a:r>
+            <a:r>
+              <a:rPr sz="1500" b="1" i="0" u="none" dirty="0">
+                <a:solidFill>
+                  <a:srgbClr val="000000"/>
+                </a:solidFill>
+                <a:latin typeface="Arial"/>
+                <a:ea typeface="Arial"/>
+                <a:cs typeface="Arial"/>
+              </a:rPr>
+              <a:t> Dane)</a:t>
+            </a:r>
+            <a:endParaRPr sz="1500" dirty="0">
               <a:latin typeface="Arial"/>
               <a:cs typeface="Arial"/>
             </a:endParaRPr>
@@ -4051,17 +4044,50 @@
               <a:defRPr/>
             </a:pPr>
             <a:r>
-              <a:rPr sz="1500" b="1" i="0" u="none">
-                <a:solidFill>
-                  <a:srgbClr val="000000"/>
-                </a:solidFill>
-                <a:latin typeface="Arial"/>
-                <a:ea typeface="Arial"/>
-                <a:cs typeface="Arial"/>
-              </a:rPr>
-              <a:t>A. Technologie i Algorytm</a:t>
-            </a:r>
-            <a:endParaRPr sz="1500">
+              <a:rPr sz="1500" b="1" i="0" u="none" dirty="0">
+                <a:solidFill>
+                  <a:srgbClr val="000000"/>
+                </a:solidFill>
+                <a:latin typeface="Arial"/>
+                <a:ea typeface="Arial"/>
+                <a:cs typeface="Arial"/>
+              </a:rPr>
+              <a:t>A. Technologie </a:t>
+            </a:r>
+            <a:r>
+              <a:rPr sz="1500" b="1" i="0" u="none" dirty="0" err="1">
+                <a:solidFill>
+                  <a:srgbClr val="000000"/>
+                </a:solidFill>
+                <a:latin typeface="Arial"/>
+                <a:ea typeface="Arial"/>
+                <a:cs typeface="Arial"/>
+              </a:rPr>
+              <a:t>i</a:t>
+            </a:r>
+            <a:r>
+              <a:rPr sz="1500" b="1" i="0" u="none" dirty="0">
+                <a:solidFill>
+                  <a:srgbClr val="000000"/>
+                </a:solidFill>
+                <a:latin typeface="Arial"/>
+                <a:ea typeface="Arial"/>
+                <a:cs typeface="Arial"/>
+              </a:rPr>
+              <a:t> </a:t>
+            </a:r>
+            <a:r>
+              <a:rPr sz="1500" b="1" i="0" u="none" dirty="0" err="1">
+                <a:solidFill>
+                  <a:srgbClr val="000000"/>
+                </a:solidFill>
+                <a:latin typeface="Arial"/>
+                <a:ea typeface="Arial"/>
+                <a:cs typeface="Arial"/>
+              </a:rPr>
+              <a:t>Algorytm</a:t>
+            </a:r>
+            <a:endParaRPr sz="1500" dirty="0">
               <a:latin typeface="Arial"/>
               <a:cs typeface="Arial"/>
             </a:endParaRPr>
@@ -4071,39 +4097,39 @@
               <a:defRPr/>
             </a:pPr>
             <a:r>
-              <a:rPr sz="1500" b="1" i="0" u="none">
-                <a:solidFill>
-                  <a:srgbClr val="000000"/>
-                </a:solidFill>
-                <a:latin typeface="Arial"/>
-                <a:ea typeface="Arial"/>
-                <a:cs typeface="Arial"/>
-              </a:rPr>
-              <a:t>Język:</a:t>
-            </a:r>
-            <a:r>
-              <a:rPr sz="1500" b="0" i="0" u="none">
-                <a:solidFill>
-                  <a:srgbClr val="000000"/>
-                </a:solidFill>
-                <a:latin typeface="Arial"/>
-                <a:ea typeface="Arial"/>
-                <a:cs typeface="Arial"/>
-              </a:rPr>
-              <a:t> </a:t>
-            </a:r>
-            <a:r>
-              <a:rPr sz="1500" b="0" i="0" u="none">
-                <a:solidFill>
-                  <a:srgbClr val="000000"/>
-                </a:solidFill>
-                <a:latin typeface="Arial"/>
-                <a:ea typeface="Arial"/>
-                <a:cs typeface="Arial"/>
-              </a:rPr>
-              <a:t>Python (np. Scikit-learn, Pandas)</a:t>
-            </a:r>
-            <a:endParaRPr sz="1500">
+              <a:rPr sz="1500" b="1" i="0" u="none" dirty="0" err="1">
+                <a:solidFill>
+                  <a:srgbClr val="000000"/>
+                </a:solidFill>
+                <a:latin typeface="Arial"/>
+                <a:ea typeface="Arial"/>
+                <a:cs typeface="Arial"/>
+              </a:rPr>
+              <a:t>Język</a:t>
+            </a:r>
+            <a:r>
+              <a:rPr sz="1500" b="1" i="0" u="none" dirty="0">
+                <a:solidFill>
+                  <a:srgbClr val="000000"/>
+                </a:solidFill>
+                <a:latin typeface="Arial"/>
+                <a:ea typeface="Arial"/>
+                <a:cs typeface="Arial"/>
+              </a:rPr>
+              <a:t>:</a:t>
+            </a:r>
+            <a:r>
+              <a:rPr sz="1500" b="0" i="0" u="none" dirty="0">
+                <a:solidFill>
+                  <a:srgbClr val="000000"/>
+                </a:solidFill>
+                <a:latin typeface="Arial"/>
+                <a:ea typeface="Arial"/>
+                <a:cs typeface="Arial"/>
+              </a:rPr>
+              <a:t> Python (np. Scikit-learn, Pandas)</a:t>
+            </a:r>
+            <a:endParaRPr sz="1500" dirty="0">
               <a:latin typeface="Arial"/>
               <a:cs typeface="Arial"/>
             </a:endParaRPr>
@@ -4113,7 +4139,7 @@
               <a:defRPr/>
             </a:pPr>
             <a:r>
-              <a:rPr sz="1500" b="1" i="0" u="none">
+              <a:rPr sz="1500" b="1" i="0" u="none" dirty="0">
                 <a:solidFill>
                   <a:srgbClr val="000000"/>
                 </a:solidFill>
@@ -4124,7 +4150,7 @@
               <a:t>Model AI:</a:t>
             </a:r>
             <a:r>
-              <a:rPr sz="1500" b="0" i="0" u="none">
+              <a:rPr sz="1500" b="0" i="0" u="none" dirty="0">
                 <a:solidFill>
                   <a:srgbClr val="000000"/>
                 </a:solidFill>
@@ -4135,18 +4161,18 @@
               <a:t> </a:t>
             </a:r>
             <a:r>
-              <a:rPr sz="1500" b="0" i="0" u="none">
-                <a:solidFill>
-                  <a:srgbClr val="000000"/>
-                </a:solidFill>
-                <a:latin typeface="Arial"/>
-                <a:ea typeface="Arial"/>
-                <a:cs typeface="Arial"/>
-              </a:rPr>
-              <a:t>Drzewa Decyzyjne (Decision Tree) –</a:t>
-            </a:r>
-            <a:r>
-              <a:rPr sz="1500" b="0" i="0" u="none">
+              <a:rPr sz="1500" b="0" i="0" u="none" dirty="0" err="1">
+                <a:solidFill>
+                  <a:srgbClr val="000000"/>
+                </a:solidFill>
+                <a:latin typeface="Arial"/>
+                <a:ea typeface="Arial"/>
+                <a:cs typeface="Arial"/>
+              </a:rPr>
+              <a:t>Drzewa</a:t>
+            </a:r>
+            <a:r>
+              <a:rPr sz="1500" b="0" i="0" u="none" dirty="0">
                 <a:solidFill>
                   <a:srgbClr val="000000"/>
                 </a:solidFill>
@@ -4157,17 +4183,182 @@
               <a:t> </a:t>
             </a:r>
             <a:r>
-              <a:rPr sz="1500" b="0" i="1" u="none">
-                <a:solidFill>
-                  <a:srgbClr val="000000"/>
-                </a:solidFill>
-                <a:latin typeface="Arial"/>
-                <a:ea typeface="Arial"/>
-                <a:cs typeface="Arial"/>
-              </a:rPr>
-              <a:t>wybrane ze względu na łatwość interpretacji reguł decyzyjnych.</a:t>
-            </a:r>
-            <a:endParaRPr sz="1500">
+              <a:rPr sz="1500" b="0" i="0" u="none" dirty="0" err="1">
+                <a:solidFill>
+                  <a:srgbClr val="000000"/>
+                </a:solidFill>
+                <a:latin typeface="Arial"/>
+                <a:ea typeface="Arial"/>
+                <a:cs typeface="Arial"/>
+              </a:rPr>
+              <a:t>Decyzyjne</a:t>
+            </a:r>
+            <a:r>
+              <a:rPr sz="1500" b="0" i="0" u="none" dirty="0">
+                <a:solidFill>
+                  <a:srgbClr val="000000"/>
+                </a:solidFill>
+                <a:latin typeface="Arial"/>
+                <a:ea typeface="Arial"/>
+                <a:cs typeface="Arial"/>
+              </a:rPr>
+              <a:t> (Decision Tree) – </a:t>
+            </a:r>
+            <a:r>
+              <a:rPr sz="1500" b="0" i="1" u="none" dirty="0" err="1">
+                <a:solidFill>
+                  <a:srgbClr val="000000"/>
+                </a:solidFill>
+                <a:latin typeface="Arial"/>
+                <a:ea typeface="Arial"/>
+                <a:cs typeface="Arial"/>
+              </a:rPr>
+              <a:t>wybrane</a:t>
+            </a:r>
+            <a:r>
+              <a:rPr sz="1500" b="0" i="1" u="none" dirty="0">
+                <a:solidFill>
+                  <a:srgbClr val="000000"/>
+                </a:solidFill>
+                <a:latin typeface="Arial"/>
+                <a:ea typeface="Arial"/>
+                <a:cs typeface="Arial"/>
+              </a:rPr>
+              <a:t> ze </a:t>
+            </a:r>
+            <a:r>
+              <a:rPr sz="1500" b="0" i="1" u="none" dirty="0" err="1">
+                <a:solidFill>
+                  <a:srgbClr val="000000"/>
+                </a:solidFill>
+                <a:latin typeface="Arial"/>
+                <a:ea typeface="Arial"/>
+                <a:cs typeface="Arial"/>
+              </a:rPr>
+              <a:t>względu</a:t>
+            </a:r>
+            <a:r>
+              <a:rPr sz="1500" b="0" i="1" u="none" dirty="0">
+                <a:solidFill>
+                  <a:srgbClr val="000000"/>
+                </a:solidFill>
+                <a:latin typeface="Arial"/>
+                <a:ea typeface="Arial"/>
+                <a:cs typeface="Arial"/>
+              </a:rPr>
+              <a:t> </a:t>
+            </a:r>
+            <a:r>
+              <a:rPr sz="1500" b="0" i="1" u="none" dirty="0" err="1">
+                <a:solidFill>
+                  <a:srgbClr val="000000"/>
+                </a:solidFill>
+                <a:latin typeface="Arial"/>
+                <a:ea typeface="Arial"/>
+                <a:cs typeface="Arial"/>
+              </a:rPr>
+              <a:t>na</a:t>
+            </a:r>
+            <a:r>
+              <a:rPr sz="1500" b="0" i="1" u="none" dirty="0">
+                <a:solidFill>
+                  <a:srgbClr val="000000"/>
+                </a:solidFill>
+                <a:latin typeface="Arial"/>
+                <a:ea typeface="Arial"/>
+                <a:cs typeface="Arial"/>
+              </a:rPr>
+              <a:t> </a:t>
+            </a:r>
+            <a:r>
+              <a:rPr sz="1500" b="0" i="1" u="none" dirty="0" err="1">
+                <a:solidFill>
+                  <a:srgbClr val="000000"/>
+                </a:solidFill>
+                <a:latin typeface="Arial"/>
+                <a:ea typeface="Arial"/>
+                <a:cs typeface="Arial"/>
+              </a:rPr>
+              <a:t>łatwość</a:t>
+            </a:r>
+            <a:r>
+              <a:rPr sz="1500" b="0" i="1" u="none" dirty="0">
+                <a:solidFill>
+                  <a:srgbClr val="000000"/>
+                </a:solidFill>
+                <a:latin typeface="Arial"/>
+                <a:ea typeface="Arial"/>
+                <a:cs typeface="Arial"/>
+              </a:rPr>
+              <a:t> </a:t>
+            </a:r>
+            <a:r>
+              <a:rPr sz="1500" b="0" i="1" u="none" dirty="0" err="1">
+                <a:solidFill>
+                  <a:srgbClr val="000000"/>
+                </a:solidFill>
+                <a:latin typeface="Arial"/>
+                <a:ea typeface="Arial"/>
+                <a:cs typeface="Arial"/>
+              </a:rPr>
+              <a:t>interpretacji</a:t>
+            </a:r>
+            <a:r>
+              <a:rPr sz="1500" b="0" i="1" u="none" dirty="0">
+                <a:solidFill>
+                  <a:srgbClr val="000000"/>
+                </a:solidFill>
+                <a:latin typeface="Arial"/>
+                <a:ea typeface="Arial"/>
+                <a:cs typeface="Arial"/>
+              </a:rPr>
+              <a:t> </a:t>
+            </a:r>
+            <a:r>
+              <a:rPr sz="1500" b="0" i="1" u="none" dirty="0" err="1">
+                <a:solidFill>
+                  <a:srgbClr val="000000"/>
+                </a:solidFill>
+                <a:latin typeface="Arial"/>
+                <a:ea typeface="Arial"/>
+                <a:cs typeface="Arial"/>
+              </a:rPr>
+              <a:t>reguł</a:t>
+            </a:r>
+            <a:r>
+              <a:rPr sz="1500" b="0" i="1" u="none" dirty="0">
+                <a:solidFill>
+                  <a:srgbClr val="000000"/>
+                </a:solidFill>
+                <a:latin typeface="Arial"/>
+                <a:ea typeface="Arial"/>
+                <a:cs typeface="Arial"/>
+              </a:rPr>
+              <a:t> </a:t>
+            </a:r>
+            <a:r>
+              <a:rPr sz="1500" b="0" i="1" u="none" dirty="0" err="1">
+                <a:solidFill>
+                  <a:srgbClr val="000000"/>
+                </a:solidFill>
+                <a:latin typeface="Arial"/>
+                <a:ea typeface="Arial"/>
+                <a:cs typeface="Arial"/>
+              </a:rPr>
+              <a:t>decyzyjnych</a:t>
+            </a:r>
+            <a:r>
+              <a:rPr sz="1500" b="0" i="1" u="none" dirty="0">
+                <a:solidFill>
+                  <a:srgbClr val="000000"/>
+                </a:solidFill>
+                <a:latin typeface="Arial"/>
+                <a:ea typeface="Arial"/>
+                <a:cs typeface="Arial"/>
+              </a:rPr>
+              <a:t>.</a:t>
+            </a:r>
+            <a:endParaRPr sz="1500" dirty="0">
               <a:latin typeface="Arial"/>
               <a:cs typeface="Arial"/>
             </a:endParaRPr>
@@ -4177,17 +4368,105 @@
               <a:defRPr/>
             </a:pPr>
             <a:r>
-              <a:rPr sz="1500" b="1" i="0" u="none">
-                <a:solidFill>
-                  <a:srgbClr val="000000"/>
-                </a:solidFill>
-                <a:latin typeface="Arial"/>
-                <a:ea typeface="Arial"/>
-                <a:cs typeface="Arial"/>
-              </a:rPr>
-              <a:t>B. Pochodzenie danych (Zestaw uczący)</a:t>
-            </a:r>
-            <a:endParaRPr sz="1500">
+              <a:rPr sz="1500" b="1" i="0" u="none" dirty="0">
+                <a:solidFill>
+                  <a:srgbClr val="000000"/>
+                </a:solidFill>
+                <a:latin typeface="Arial"/>
+                <a:ea typeface="Arial"/>
+                <a:cs typeface="Arial"/>
+              </a:rPr>
+              <a:t>B. </a:t>
+            </a:r>
+            <a:r>
+              <a:rPr sz="1500" b="1" i="0" u="none" dirty="0" err="1">
+                <a:solidFill>
+                  <a:srgbClr val="000000"/>
+                </a:solidFill>
+                <a:latin typeface="Arial"/>
+                <a:ea typeface="Arial"/>
+                <a:cs typeface="Arial"/>
+              </a:rPr>
+              <a:t>Pochodzenie</a:t>
+            </a:r>
+            <a:r>
+              <a:rPr sz="1500" b="1" i="0" u="none" dirty="0">
+                <a:solidFill>
+                  <a:srgbClr val="000000"/>
+                </a:solidFill>
+                <a:latin typeface="Arial"/>
+                <a:ea typeface="Arial"/>
+                <a:cs typeface="Arial"/>
+              </a:rPr>
+              <a:t> </a:t>
+            </a:r>
+            <a:r>
+              <a:rPr sz="1500" b="1" i="0" u="none" dirty="0" err="1">
+                <a:solidFill>
+                  <a:srgbClr val="000000"/>
+                </a:solidFill>
+                <a:latin typeface="Arial"/>
+                <a:ea typeface="Arial"/>
+                <a:cs typeface="Arial"/>
+              </a:rPr>
+              <a:t>danych</a:t>
+            </a:r>
+            <a:r>
+              <a:rPr sz="1500" b="1" i="0" u="none" dirty="0">
+                <a:solidFill>
+                  <a:srgbClr val="000000"/>
+                </a:solidFill>
+                <a:latin typeface="Arial"/>
+                <a:ea typeface="Arial"/>
+                <a:cs typeface="Arial"/>
+              </a:rPr>
+              <a:t> (</a:t>
+            </a:r>
+            <a:r>
+              <a:rPr sz="1500" b="1" i="0" u="none" dirty="0" err="1">
+                <a:solidFill>
+                  <a:srgbClr val="000000"/>
+                </a:solidFill>
+                <a:latin typeface="Arial"/>
+                <a:ea typeface="Arial"/>
+                <a:cs typeface="Arial"/>
+              </a:rPr>
+              <a:t>Zestaw</a:t>
+            </a:r>
+            <a:r>
+              <a:rPr sz="1500" b="1" i="0" u="none" dirty="0">
+                <a:solidFill>
+                  <a:srgbClr val="000000"/>
+                </a:solidFill>
+                <a:latin typeface="Arial"/>
+                <a:ea typeface="Arial"/>
+                <a:cs typeface="Arial"/>
+              </a:rPr>
+              <a:t> </a:t>
+            </a:r>
+            <a:r>
+              <a:rPr sz="1500" b="1" i="0" u="none" dirty="0" err="1">
+                <a:solidFill>
+                  <a:srgbClr val="000000"/>
+                </a:solidFill>
+                <a:latin typeface="Arial"/>
+                <a:ea typeface="Arial"/>
+                <a:cs typeface="Arial"/>
+              </a:rPr>
+              <a:t>uczący</a:t>
+            </a:r>
+            <a:r>
+              <a:rPr sz="1500" b="1" i="0" u="none" dirty="0">
+                <a:solidFill>
+                  <a:srgbClr val="000000"/>
+                </a:solidFill>
+                <a:latin typeface="Arial"/>
+                <a:ea typeface="Arial"/>
+                <a:cs typeface="Arial"/>
+              </a:rPr>
+              <a:t>)</a:t>
+            </a:r>
+            <a:endParaRPr sz="1500" dirty="0">
               <a:latin typeface="Arial"/>
               <a:cs typeface="Arial"/>
             </a:endParaRPr>
@@ -4197,18 +4476,29 @@
               <a:defRPr/>
             </a:pPr>
             <a:r>
-              <a:rPr sz="1500" b="1" i="0" u="none">
-                <a:solidFill>
-                  <a:srgbClr val="000000"/>
-                </a:solidFill>
-                <a:latin typeface="Arial"/>
-                <a:ea typeface="Arial"/>
-                <a:cs typeface="Arial"/>
-              </a:rPr>
-              <a:t>Źródła:</a:t>
-            </a:r>
-            <a:r>
-              <a:rPr sz="1500" b="0" i="0" u="none">
+              <a:rPr sz="1500" b="1" i="0" u="none" dirty="0" err="1">
+                <a:solidFill>
+                  <a:srgbClr val="000000"/>
+                </a:solidFill>
+                <a:latin typeface="Arial"/>
+                <a:ea typeface="Arial"/>
+                <a:cs typeface="Arial"/>
+              </a:rPr>
+              <a:t>Źródła</a:t>
+            </a:r>
+            <a:r>
+              <a:rPr sz="1500" b="1" i="0" u="none" dirty="0">
+                <a:solidFill>
+                  <a:srgbClr val="000000"/>
+                </a:solidFill>
+                <a:latin typeface="Arial"/>
+                <a:ea typeface="Arial"/>
+                <a:cs typeface="Arial"/>
+              </a:rPr>
+              <a:t>:</a:t>
+            </a:r>
+            <a:r>
+              <a:rPr sz="1500" b="0" i="0" u="none" dirty="0">
                 <a:solidFill>
                   <a:srgbClr val="000000"/>
                 </a:solidFill>
@@ -4219,17 +4509,50 @@
               <a:t> </a:t>
             </a:r>
             <a:r>
-              <a:rPr sz="1500" b="0" i="0" u="none">
-                <a:solidFill>
-                  <a:srgbClr val="000000"/>
-                </a:solidFill>
-                <a:latin typeface="Arial"/>
-                <a:ea typeface="Arial"/>
-                <a:cs typeface="Arial"/>
-              </a:rPr>
-              <a:t>Otwarte Dane Gdańsk (API ZTM), rozkłady GTFS</a:t>
-            </a:r>
-            <a:endParaRPr sz="1500">
+              <a:rPr sz="1500" b="0" i="0" u="none" dirty="0" err="1">
+                <a:solidFill>
+                  <a:srgbClr val="000000"/>
+                </a:solidFill>
+                <a:latin typeface="Arial"/>
+                <a:ea typeface="Arial"/>
+                <a:cs typeface="Arial"/>
+              </a:rPr>
+              <a:t>Otwarte</a:t>
+            </a:r>
+            <a:r>
+              <a:rPr sz="1500" b="0" i="0" u="none" dirty="0">
+                <a:solidFill>
+                  <a:srgbClr val="000000"/>
+                </a:solidFill>
+                <a:latin typeface="Arial"/>
+                <a:ea typeface="Arial"/>
+                <a:cs typeface="Arial"/>
+              </a:rPr>
+              <a:t> Dane </a:t>
+            </a:r>
+            <a:r>
+              <a:rPr sz="1500" b="0" i="0" u="none" dirty="0" err="1">
+                <a:solidFill>
+                  <a:srgbClr val="000000"/>
+                </a:solidFill>
+                <a:latin typeface="Arial"/>
+                <a:ea typeface="Arial"/>
+                <a:cs typeface="Arial"/>
+              </a:rPr>
+              <a:t>Gdańsk</a:t>
+            </a:r>
+            <a:r>
+              <a:rPr sz="1500" b="0" i="0" u="none" dirty="0">
+                <a:solidFill>
+                  <a:srgbClr val="000000"/>
+                </a:solidFill>
+                <a:latin typeface="Arial"/>
+                <a:ea typeface="Arial"/>
+                <a:cs typeface="Arial"/>
+              </a:rPr>
+              <a:t> (API ZTM)</a:t>
+            </a:r>
+            <a:endParaRPr sz="1500" dirty="0">
               <a:latin typeface="Arial"/>
               <a:cs typeface="Arial"/>
             </a:endParaRPr>
@@ -4239,18 +4562,29 @@
               <a:defRPr/>
             </a:pPr>
             <a:r>
-              <a:rPr sz="1500" b="1" i="0" u="none">
-                <a:solidFill>
-                  <a:srgbClr val="000000"/>
-                </a:solidFill>
-                <a:latin typeface="Arial"/>
-                <a:ea typeface="Arial"/>
-                <a:cs typeface="Arial"/>
-              </a:rPr>
-              <a:t>Struktura:</a:t>
-            </a:r>
-            <a:r>
-              <a:rPr sz="1500" b="0" i="0" u="none">
+              <a:rPr sz="1500" b="1" i="0" u="none" dirty="0" err="1">
+                <a:solidFill>
+                  <a:srgbClr val="000000"/>
+                </a:solidFill>
+                <a:latin typeface="Arial"/>
+                <a:ea typeface="Arial"/>
+                <a:cs typeface="Arial"/>
+              </a:rPr>
+              <a:t>Struktura</a:t>
+            </a:r>
+            <a:r>
+              <a:rPr sz="1500" b="1" i="0" u="none" dirty="0">
+                <a:solidFill>
+                  <a:srgbClr val="000000"/>
+                </a:solidFill>
+                <a:latin typeface="Arial"/>
+                <a:ea typeface="Arial"/>
+                <a:cs typeface="Arial"/>
+              </a:rPr>
+              <a:t>:</a:t>
+            </a:r>
+            <a:r>
+              <a:rPr sz="1500" b="0" i="0" u="none" dirty="0">
                 <a:solidFill>
                   <a:srgbClr val="000000"/>
                 </a:solidFill>
@@ -4261,17 +4595,28 @@
               <a:t> </a:t>
             </a:r>
             <a:r>
-              <a:rPr sz="1500" b="0" i="0" u="none">
-                <a:solidFill>
-                  <a:srgbClr val="000000"/>
-                </a:solidFill>
-                <a:latin typeface="Arial"/>
-                <a:ea typeface="Arial"/>
-                <a:cs typeface="Arial"/>
-              </a:rPr>
-              <a:t>Połączenie rozkładów teoretycznych z historycznymi danymi o rzeczywistych opóźnieniach.</a:t>
-            </a:r>
-            <a:endParaRPr sz="1500">
+              <a:rPr lang="pl-PL" sz="1500" b="0" i="0" u="none" dirty="0">
+                <a:solidFill>
+                  <a:srgbClr val="000000"/>
+                </a:solidFill>
+                <a:latin typeface="Arial"/>
+                <a:ea typeface="Arial"/>
+                <a:cs typeface="Arial"/>
+              </a:rPr>
+              <a:t>Wykorzystanie rozkładów jazdy GTFS, ewentualne uwzględnienie danych czasu rzeczywistego</a:t>
+            </a:r>
+            <a:r>
+              <a:rPr sz="1500" b="0" i="0" u="none" dirty="0">
+                <a:solidFill>
+                  <a:srgbClr val="000000"/>
+                </a:solidFill>
+                <a:latin typeface="Arial"/>
+                <a:ea typeface="Arial"/>
+                <a:cs typeface="Arial"/>
+              </a:rPr>
+              <a:t>.</a:t>
+            </a:r>
+            <a:endParaRPr sz="1500" dirty="0">
               <a:latin typeface="Arial"/>
               <a:cs typeface="Arial"/>
             </a:endParaRPr>
@@ -4283,11 +4628,11 @@
   <p:clrMapOvr>
     <a:masterClrMapping/>
   </p:clrMapOvr>
-  <mc:AlternateContent xmlns:mc="http://schemas.openxmlformats.org/markup-compatibility/2006">
-    <mc:Choice xmlns:p159="http://schemas.microsoft.com/office/powerpoint/2015/09/main" xmlns:p14="http://schemas.microsoft.com/office/powerpoint/2010/main" Requires="p159">
-      <p:transition p14:dur="500" advClick="1"/>
+  <mc:AlternateContent xmlns:mc="http://schemas.openxmlformats.org/markup-compatibility/2006" xmlns:p159="http://schemas.microsoft.com/office/powerpoint/2015/09/main">
+    <mc:Choice Requires="p159">
+      <p:transition/>
     </mc:Choice>
-    <mc:Fallback>
+    <mc:Fallback xmlns:w="http://schemas.openxmlformats.org/wordprocessingml/2006/main" xmlns:m="http://schemas.openxmlformats.org/officeDocument/2006/math" xmlns="">
       <p:transition advClick="1"/>
     </mc:Fallback>
   </mc:AlternateContent>
@@ -4295,7 +4640,7 @@
 </file>
 
 <file path=ppt/theme/theme1.xml><?xml version="1.0" encoding="utf-8"?>
-<a:theme xmlns:a="http://schemas.openxmlformats.org/drawingml/2006/main" xmlns:r="http://schemas.openxmlformats.org/officeDocument/2006/relationships" xmlns:p="http://schemas.openxmlformats.org/presentationml/2006/main" name="Office Theme">
+<a:theme xmlns:a="http://schemas.openxmlformats.org/drawingml/2006/main" name="Office Theme">
   <a:themeElements>
     <a:clrScheme name="New Office">
       <a:dk1>
@@ -4486,11 +4831,12 @@
     </a:fmtScheme>
   </a:themeElements>
   <a:objectDefaults/>
+  <a:extraClrSchemeLst/>
 </a:theme>
 </file>
 
 <file path=ppt/theme/theme2.xml><?xml version="1.0" encoding="utf-8"?>
-<a:theme xmlns:a="http://schemas.openxmlformats.org/drawingml/2006/main" xmlns:r="http://schemas.openxmlformats.org/officeDocument/2006/relationships" xmlns:p="http://schemas.openxmlformats.org/presentationml/2006/main" name="Office Theme">
+<a:theme xmlns:a="http://schemas.openxmlformats.org/drawingml/2006/main" name="Office Theme">
   <a:themeElements>
     <a:clrScheme name="Office">
       <a:dk1>
@@ -4681,5 +5027,6 @@
     </a:fmtScheme>
   </a:themeElements>
   <a:objectDefaults/>
+  <a:extraClrSchemeLst/>
 </a:theme>
 </file>
</xml_diff>